<commit_message>
Slides: sd-01-033 and sd-01-034 PPTX with every line at ten words or fewer
Co-Authored-By: Claude Opus 5.5 <noreply@anthropic.com>
Claude-Session: https://claude.ai/code/session_01PmqNRWe4NoiAuhPfHYj9Qq
</commit_message>
<xml_diff>
--- a/system-design-101/vi/lessons/sd-01-033/slides/sd-01-033.pptx
+++ b/system-design-101/vi/lessons/sd-01-033/slides/sd-01-033.pptx
@@ -1778,8 +1778,17 @@
               </a:rPr>
               <a:t> tiếp:</a:t>
             </a:r>
-            <a:r>
-              <a:rPr lang="en-US" sz="8100" dirty="0" spc="-4" kern="0">
+            <a:endParaRPr lang="en-US" sz="8100" dirty="0"/>
+          </a:p>
+          <a:p>
+            <a:pPr algn="l" indent="0" marL="0">
+              <a:lnSpc>
+                <a:spcPts val="8262"/>
+              </a:lnSpc>
+              <a:buNone/>
+            </a:pPr>
+            <a:r>
+              <a:rPr lang="en-US" sz="8100" dirty="0" spc="-3" kern="0">
                 <a:solidFill>
                   <a:srgbClr val="F3EEE3"/>
                 </a:solidFill>
@@ -1787,7 +1796,7 @@
                 <a:ea typeface="Bricolage Grotesque ExtraBold" pitchFamily="34" charset="-122"/>
                 <a:cs typeface="Bricolage Grotesque ExtraBold" pitchFamily="34" charset="-120"/>
               </a:rPr>
-              <a:t> bắt</a:t>
+              <a:t>bắt</a:t>
             </a:r>
             <a:r>
               <a:rPr lang="en-US" sz="8100" dirty="0" spc="10" kern="0">
@@ -1809,7 +1818,7 @@
                 <a:ea typeface="Bricolage Grotesque ExtraBold" pitchFamily="34" charset="-122"/>
                 <a:cs typeface="Bricolage Grotesque ExtraBold" pitchFamily="34" charset="-120"/>
               </a:rPr>
-              <a:t> từ</a:t>
+              <a:t> từ nhu</a:t>
             </a:r>
             <a:r>
               <a:rPr lang="en-US" sz="8100" dirty="0" spc="-1" kern="0">
@@ -1820,7 +1829,7 @@
                 <a:ea typeface="Bricolage Grotesque ExtraBold" pitchFamily="34" charset="-122"/>
                 <a:cs typeface="Bricolage Grotesque ExtraBold" pitchFamily="34" charset="-120"/>
               </a:rPr>
-              <a:t> nhu cầu</a:t>
+              <a:t> cầu</a:t>
             </a:r>
             <a:endParaRPr lang="en-US" sz="8100" dirty="0"/>
           </a:p>

</xml_diff>